<commit_message>
Add real Google Forms responses
</commit_message>
<xml_diff>
--- a/Психологический_центр_готово/05_Практика_4_PowerPoint/Практика4_Презентация_отчета_психолога.pptx
+++ b/Психологический_центр_готово/05_Практика_4_PowerPoint/Практика4_Презентация_отчета_психолога.pptx
@@ -3939,1080 +3939,1080 @@
 </file>
 
 <file path=ppt/slides/slide5.xml><?xml version="1.0" encoding="utf-8"?>
-<p:sld xmlns:a="http://schemas.openxmlformats.org/drawingml/2006/main" xmlns:r="http://schemas.openxmlformats.org/officeDocument/2006/relationships" xmlns:p="http://schemas.openxmlformats.org/presentationml/2006/main">
-  <p:cSld name="Slide 5">
-    <p:spTree>
-      <p:nvGrpSpPr>
-        <p:cNvPr id="1" name=""/>
-        <p:cNvGrpSpPr/>
-        <p:nvPr/>
-      </p:nvGrpSpPr>
-      <p:grpSpPr>
-        <a:xfrm>
-          <a:off x="0" y="0"/>
-          <a:ext cx="0" cy="0"/>
-          <a:chOff x="0" y="0"/>
-          <a:chExt cx="0" cy="0"/>
-        </a:xfrm>
-      </p:grpSpPr>
-      <p:sp>
-        <p:nvSpPr>
-          <p:cNvPr id="2" name="Text 0"/>
-          <p:cNvSpPr/>
-          <p:nvPr/>
-        </p:nvSpPr>
-        <p:spPr>
-          <a:xfrm>
-            <a:off x="640080" y="502920"/>
-            <a:ext cx="7955280" cy="502920"/>
-          </a:xfrm>
-          <a:prstGeom prst="rect">
-            <a:avLst/>
-          </a:prstGeom>
-          <a:noFill/>
-          <a:ln/>
-        </p:spPr>
-        <p:txBody>
-          <a:bodyPr wrap="square" lIns="254" tIns="254" rIns="254" bIns="254" rtlCol="0" anchor="ctr">
-            <a:normAutofit/>
-          </a:bodyPr>
-          <a:lstStyle/>
-          <a:p>
-            <a:pPr indent="0" marL="0">
-              <a:buNone/>
-            </a:pPr>
-            <a:r>
-              <a:rPr lang="en-US" sz="2500" b="1" dirty="0">
-                <a:solidFill>
-                  <a:srgbClr val="2F686D"/>
-                </a:solidFill>
-                <a:latin typeface="Arial" pitchFamily="34" charset="0"/>
-                <a:ea typeface="Arial" pitchFamily="34" charset="-122"/>
-                <a:cs typeface="Arial" pitchFamily="34" charset="-120"/>
-              </a:rPr>
-              <a:t>Результаты анкетирования</a:t>
-            </a:r>
-            <a:endParaRPr lang="en-US" sz="2500" dirty="0"/>
-          </a:p>
-        </p:txBody>
-      </p:sp>
-      <p:sp>
-        <p:nvSpPr>
-          <p:cNvPr id="3" name="Text 1"/>
-          <p:cNvSpPr/>
-          <p:nvPr/>
-        </p:nvSpPr>
-        <p:spPr>
-          <a:xfrm>
-            <a:off x="658368" y="1024128"/>
-            <a:ext cx="7498080" cy="256032"/>
-          </a:xfrm>
-          <a:prstGeom prst="rect">
-            <a:avLst/>
-          </a:prstGeom>
-          <a:noFill/>
-          <a:ln/>
-        </p:spPr>
-        <p:txBody>
-          <a:bodyPr wrap="square" lIns="254" tIns="254" rIns="254" bIns="254" rtlCol="0" anchor="ctr"/>
-          <a:lstStyle/>
-          <a:p>
-            <a:pPr indent="0" marL="0">
-              <a:buNone/>
-            </a:pPr>
-            <a:r>
-              <a:rPr lang="en-US" sz="1100" dirty="0">
-                <a:solidFill>
-                  <a:srgbClr val="5C6E70"/>
-                </a:solidFill>
-                <a:latin typeface="Arial" pitchFamily="34" charset="0"/>
-                <a:ea typeface="Arial" pitchFamily="34" charset="-122"/>
-                <a:cs typeface="Arial" pitchFamily="34" charset="-120"/>
-              </a:rPr>
-              <a:t>Три заполненные анкеты для обработки</a:t>
-            </a:r>
-            <a:endParaRPr lang="en-US" sz="1100" dirty="0"/>
-          </a:p>
-        </p:txBody>
-      </p:sp>
-      <p:graphicFrame>
-        <p:nvGraphicFramePr>
-          <p:cNvPr id="6" name="Table 0"/>
-          <p:cNvGraphicFramePr>
-            <a:graphicFrameLocks noGrp="1"/>
-          </p:cNvGraphicFramePr>
-          <p:nvPr>
-            <p:extLst>
-              <p:ext uri="{D42A27DB-BD31-4B8C-83A1-F6EECF244321}">
-                <p14:modId xmlns:p14="http://schemas.microsoft.com/office/powerpoint/2010/main" val="1579011935"/>
-              </p:ext>
-            </p:extLst>
-          </p:nvPr>
-        </p:nvGraphicFramePr>
-        <p:xfrm>
-          <a:off x="749808" y="1444752"/>
-          <a:ext cx="6675120" cy="2194560"/>
-        </p:xfrm>
-        <a:graphic>
-          <a:graphicData uri="http://schemas.openxmlformats.org/drawingml/2006/table">
-            <a:tbl>
-              <a:tblPr/>
-              <a:tblGrid>
-                <a:gridCol w="1554480"/>
-                <a:gridCol w="1097280"/>
-                <a:gridCol w="4023360"/>
-              </a:tblGrid>
-              <a:tr h="548640">
-                <a:tc>
-                  <a:txBody>
-                    <a:bodyPr/>
-                    <a:lstStyle/>
-                    <a:p>
-                      <a:pPr indent="0" marL="0">
-                        <a:buNone/>
-                      </a:pPr>
-                      <a:r>
-                        <a:rPr lang="en-US" sz="1200" dirty="0">
-                          <a:solidFill>
-                            <a:srgbClr val="263538"/>
-                          </a:solidFill>
-                          <a:latin typeface="Arial" pitchFamily="34" charset="0"/>
-                          <a:ea typeface="Arial" pitchFamily="34" charset="-122"/>
-                          <a:cs typeface="Arial" pitchFamily="34" charset="-120"/>
-                        </a:rPr>
-                        <a:t>Респондент</a:t>
-                      </a:r>
-                      <a:endParaRPr lang="en-US" sz="1200" dirty="0">
-                        <a:latin typeface="Arial" charset="0"/>
-                        <a:ea typeface="Arial" charset="0"/>
-                        <a:cs typeface="Arial" charset="0"/>
-                      </a:endParaRPr>
-                    </a:p>
-                  </a:txBody>
-                  <a:tcPr marL="73152" marR="73152" marT="73152" marB="73152" anchor="mid">
-                    <a:lnL w="12700" cap="flat" cmpd="sng" algn="ctr">
-                      <a:solidFill>
-                        <a:srgbClr val="D7E4E1"/>
-                      </a:solidFill>
-                      <a:prstDash val="solid"/>
-                      <a:round/>
-                      <a:headEnd type="none" w="med" len="med"/>
-                      <a:tailEnd type="none" w="med" len="med"/>
-                    </a:lnL>
-                    <a:lnR w="12700" cap="flat" cmpd="sng" algn="ctr">
-                      <a:solidFill>
-                        <a:srgbClr val="D7E4E1"/>
-                      </a:solidFill>
-                      <a:prstDash val="solid"/>
-                      <a:round/>
-                      <a:headEnd type="none" w="med" len="med"/>
-                      <a:tailEnd type="none" w="med" len="med"/>
-                    </a:lnR>
-                    <a:lnT w="12700" cap="flat" cmpd="sng" algn="ctr">
-                      <a:solidFill>
-                        <a:srgbClr val="D7E4E1"/>
-                      </a:solidFill>
-                      <a:prstDash val="solid"/>
-                      <a:round/>
-                      <a:headEnd type="none" w="med" len="med"/>
-                      <a:tailEnd type="none" w="med" len="med"/>
-                    </a:lnT>
-                    <a:lnB w="12700" cap="flat" cmpd="sng" algn="ctr">
-                      <a:solidFill>
-                        <a:srgbClr val="D7E4E1"/>
-                      </a:solidFill>
-                      <a:prstDash val="solid"/>
-                      <a:round/>
-                      <a:headEnd type="none" w="med" len="med"/>
-                      <a:tailEnd type="none" w="med" len="med"/>
-                    </a:lnB>
-                    <a:solidFill>
-                      <a:srgbClr val="FFFFFF"/>
-                    </a:solidFill>
-                  </a:tcPr>
-                </a:tc>
-                <a:tc>
-                  <a:txBody>
-                    <a:bodyPr/>
-                    <a:lstStyle/>
-                    <a:p>
-                      <a:pPr indent="0" marL="0">
-                        <a:buNone/>
-                      </a:pPr>
-                      <a:r>
-                        <a:rPr lang="en-US" sz="1200" dirty="0">
-                          <a:solidFill>
-                            <a:srgbClr val="263538"/>
-                          </a:solidFill>
-                          <a:latin typeface="Arial" pitchFamily="34" charset="0"/>
-                          <a:ea typeface="Arial" pitchFamily="34" charset="-122"/>
-                          <a:cs typeface="Arial" pitchFamily="34" charset="-120"/>
-                        </a:rPr>
-                        <a:t>Баллы</a:t>
-                      </a:r>
-                      <a:endParaRPr lang="en-US" sz="1200" dirty="0">
-                        <a:latin typeface="Arial" charset="0"/>
-                        <a:ea typeface="Arial" charset="0"/>
-                        <a:cs typeface="Arial" charset="0"/>
-                      </a:endParaRPr>
-                    </a:p>
-                  </a:txBody>
-                  <a:tcPr marL="73152" marR="73152" marT="73152" marB="73152" anchor="mid">
-                    <a:lnL w="12700" cap="flat" cmpd="sng" algn="ctr">
-                      <a:solidFill>
-                        <a:srgbClr val="D7E4E1"/>
-                      </a:solidFill>
-                      <a:prstDash val="solid"/>
-                      <a:round/>
-                      <a:headEnd type="none" w="med" len="med"/>
-                      <a:tailEnd type="none" w="med" len="med"/>
-                    </a:lnL>
-                    <a:lnR w="12700" cap="flat" cmpd="sng" algn="ctr">
-                      <a:solidFill>
-                        <a:srgbClr val="D7E4E1"/>
-                      </a:solidFill>
-                      <a:prstDash val="solid"/>
-                      <a:round/>
-                      <a:headEnd type="none" w="med" len="med"/>
-                      <a:tailEnd type="none" w="med" len="med"/>
-                    </a:lnR>
-                    <a:lnT w="12700" cap="flat" cmpd="sng" algn="ctr">
-                      <a:solidFill>
-                        <a:srgbClr val="D7E4E1"/>
-                      </a:solidFill>
-                      <a:prstDash val="solid"/>
-                      <a:round/>
-                      <a:headEnd type="none" w="med" len="med"/>
-                      <a:tailEnd type="none" w="med" len="med"/>
-                    </a:lnT>
-                    <a:lnB w="12700" cap="flat" cmpd="sng" algn="ctr">
-                      <a:solidFill>
-                        <a:srgbClr val="D7E4E1"/>
-                      </a:solidFill>
-                      <a:prstDash val="solid"/>
-                      <a:round/>
-                      <a:headEnd type="none" w="med" len="med"/>
-                      <a:tailEnd type="none" w="med" len="med"/>
-                    </a:lnB>
-                    <a:solidFill>
-                      <a:srgbClr val="FFFFFF"/>
-                    </a:solidFill>
-                  </a:tcPr>
-                </a:tc>
-                <a:tc>
-                  <a:txBody>
-                    <a:bodyPr/>
-                    <a:lstStyle/>
-                    <a:p>
-                      <a:pPr indent="0" marL="0">
-                        <a:buNone/>
-                      </a:pPr>
-                      <a:r>
-                        <a:rPr lang="en-US" sz="1200" dirty="0">
-                          <a:solidFill>
-                            <a:srgbClr val="263538"/>
-                          </a:solidFill>
-                          <a:latin typeface="Arial" pitchFamily="34" charset="0"/>
-                          <a:ea typeface="Arial" pitchFamily="34" charset="-122"/>
-                          <a:cs typeface="Arial" pitchFamily="34" charset="-120"/>
-                        </a:rPr>
-                        <a:t>Интерпретация</a:t>
-                      </a:r>
-                      <a:endParaRPr lang="en-US" sz="1200" dirty="0">
-                        <a:latin typeface="Arial" charset="0"/>
-                        <a:ea typeface="Arial" charset="0"/>
-                        <a:cs typeface="Arial" charset="0"/>
-                      </a:endParaRPr>
-                    </a:p>
-                  </a:txBody>
-                  <a:tcPr marL="73152" marR="73152" marT="73152" marB="73152" anchor="mid">
-                    <a:lnL w="12700" cap="flat" cmpd="sng" algn="ctr">
-                      <a:solidFill>
-                        <a:srgbClr val="D7E4E1"/>
-                      </a:solidFill>
-                      <a:prstDash val="solid"/>
-                      <a:round/>
-                      <a:headEnd type="none" w="med" len="med"/>
-                      <a:tailEnd type="none" w="med" len="med"/>
-                    </a:lnL>
-                    <a:lnR w="12700" cap="flat" cmpd="sng" algn="ctr">
-                      <a:solidFill>
-                        <a:srgbClr val="D7E4E1"/>
-                      </a:solidFill>
-                      <a:prstDash val="solid"/>
-                      <a:round/>
-                      <a:headEnd type="none" w="med" len="med"/>
-                      <a:tailEnd type="none" w="med" len="med"/>
-                    </a:lnR>
-                    <a:lnT w="12700" cap="flat" cmpd="sng" algn="ctr">
-                      <a:solidFill>
-                        <a:srgbClr val="D7E4E1"/>
-                      </a:solidFill>
-                      <a:prstDash val="solid"/>
-                      <a:round/>
-                      <a:headEnd type="none" w="med" len="med"/>
-                      <a:tailEnd type="none" w="med" len="med"/>
-                    </a:lnT>
-                    <a:lnB w="12700" cap="flat" cmpd="sng" algn="ctr">
-                      <a:solidFill>
-                        <a:srgbClr val="D7E4E1"/>
-                      </a:solidFill>
-                      <a:prstDash val="solid"/>
-                      <a:round/>
-                      <a:headEnd type="none" w="med" len="med"/>
-                      <a:tailEnd type="none" w="med" len="med"/>
-                    </a:lnB>
-                    <a:solidFill>
-                      <a:srgbClr val="FFFFFF"/>
-                    </a:solidFill>
-                  </a:tcPr>
-                </a:tc>
-              </a:tr>
-              <a:tr h="548640">
-                <a:tc>
-                  <a:txBody>
-                    <a:bodyPr/>
-                    <a:lstStyle/>
-                    <a:p>
-                      <a:pPr indent="0" marL="0">
-                        <a:buNone/>
-                      </a:pPr>
-                      <a:r>
-                        <a:rPr lang="en-US" sz="1200" dirty="0">
-                          <a:solidFill>
-                            <a:srgbClr val="263538"/>
-                          </a:solidFill>
-                          <a:latin typeface="Arial" pitchFamily="34" charset="0"/>
-                          <a:ea typeface="Arial" pitchFamily="34" charset="-122"/>
-                          <a:cs typeface="Arial" pitchFamily="34" charset="-120"/>
-                        </a:rPr>
-                        <a:t>1</a:t>
-                      </a:r>
-                      <a:endParaRPr lang="en-US" sz="1200" dirty="0">
-                        <a:latin typeface="Arial" charset="0"/>
-                        <a:ea typeface="Arial" charset="0"/>
-                        <a:cs typeface="Arial" charset="0"/>
-                      </a:endParaRPr>
-                    </a:p>
-                  </a:txBody>
-                  <a:tcPr marL="73152" marR="73152" marT="73152" marB="73152" anchor="mid">
-                    <a:lnL w="12700" cap="flat" cmpd="sng" algn="ctr">
-                      <a:solidFill>
-                        <a:srgbClr val="D7E4E1"/>
-                      </a:solidFill>
-                      <a:prstDash val="solid"/>
-                      <a:round/>
-                      <a:headEnd type="none" w="med" len="med"/>
-                      <a:tailEnd type="none" w="med" len="med"/>
-                    </a:lnL>
-                    <a:lnR w="12700" cap="flat" cmpd="sng" algn="ctr">
-                      <a:solidFill>
-                        <a:srgbClr val="D7E4E1"/>
-                      </a:solidFill>
-                      <a:prstDash val="solid"/>
-                      <a:round/>
-                      <a:headEnd type="none" w="med" len="med"/>
-                      <a:tailEnd type="none" w="med" len="med"/>
-                    </a:lnR>
-                    <a:lnT w="12700" cap="flat" cmpd="sng" algn="ctr">
-                      <a:solidFill>
-                        <a:srgbClr val="D7E4E1"/>
-                      </a:solidFill>
-                      <a:prstDash val="solid"/>
-                      <a:round/>
-                      <a:headEnd type="none" w="med" len="med"/>
-                      <a:tailEnd type="none" w="med" len="med"/>
-                    </a:lnT>
-                    <a:lnB w="12700" cap="flat" cmpd="sng" algn="ctr">
-                      <a:solidFill>
-                        <a:srgbClr val="D7E4E1"/>
-                      </a:solidFill>
-                      <a:prstDash val="solid"/>
-                      <a:round/>
-                      <a:headEnd type="none" w="med" len="med"/>
-                      <a:tailEnd type="none" w="med" len="med"/>
-                    </a:lnB>
-                    <a:solidFill>
-                      <a:srgbClr val="FFFFFF"/>
-                    </a:solidFill>
-                  </a:tcPr>
-                </a:tc>
-                <a:tc>
-                  <a:txBody>
-                    <a:bodyPr/>
-                    <a:lstStyle/>
-                    <a:p>
-                      <a:pPr indent="0" marL="0">
-                        <a:buNone/>
-                      </a:pPr>
-                      <a:r>
-                        <a:rPr lang="en-US" sz="1200" dirty="0">
-                          <a:solidFill>
-                            <a:srgbClr val="263538"/>
-                          </a:solidFill>
-                          <a:latin typeface="Arial" pitchFamily="34" charset="0"/>
-                          <a:ea typeface="Arial" pitchFamily="34" charset="-122"/>
-                          <a:cs typeface="Arial" pitchFamily="34" charset="-120"/>
-                        </a:rPr>
-                        <a:t>50</a:t>
-                      </a:r>
-                      <a:endParaRPr lang="en-US" sz="1200" dirty="0">
-                        <a:latin typeface="Arial" charset="0"/>
-                        <a:ea typeface="Arial" charset="0"/>
-                        <a:cs typeface="Arial" charset="0"/>
-                      </a:endParaRPr>
-                    </a:p>
-                  </a:txBody>
-                  <a:tcPr marL="73152" marR="73152" marT="73152" marB="73152" anchor="mid">
-                    <a:lnL w="12700" cap="flat" cmpd="sng" algn="ctr">
-                      <a:solidFill>
-                        <a:srgbClr val="D7E4E1"/>
-                      </a:solidFill>
-                      <a:prstDash val="solid"/>
-                      <a:round/>
-                      <a:headEnd type="none" w="med" len="med"/>
-                      <a:tailEnd type="none" w="med" len="med"/>
-                    </a:lnL>
-                    <a:lnR w="12700" cap="flat" cmpd="sng" algn="ctr">
-                      <a:solidFill>
-                        <a:srgbClr val="D7E4E1"/>
-                      </a:solidFill>
-                      <a:prstDash val="solid"/>
-                      <a:round/>
-                      <a:headEnd type="none" w="med" len="med"/>
-                      <a:tailEnd type="none" w="med" len="med"/>
-                    </a:lnR>
-                    <a:lnT w="12700" cap="flat" cmpd="sng" algn="ctr">
-                      <a:solidFill>
-                        <a:srgbClr val="D7E4E1"/>
-                      </a:solidFill>
-                      <a:prstDash val="solid"/>
-                      <a:round/>
-                      <a:headEnd type="none" w="med" len="med"/>
-                      <a:tailEnd type="none" w="med" len="med"/>
-                    </a:lnT>
-                    <a:lnB w="12700" cap="flat" cmpd="sng" algn="ctr">
-                      <a:solidFill>
-                        <a:srgbClr val="D7E4E1"/>
-                      </a:solidFill>
-                      <a:prstDash val="solid"/>
-                      <a:round/>
-                      <a:headEnd type="none" w="med" len="med"/>
-                      <a:tailEnd type="none" w="med" len="med"/>
-                    </a:lnB>
-                    <a:solidFill>
-                      <a:srgbClr val="FFFFFF"/>
-                    </a:solidFill>
-                  </a:tcPr>
-                </a:tc>
-                <a:tc>
-                  <a:txBody>
-                    <a:bodyPr/>
-                    <a:lstStyle/>
-                    <a:p>
-                      <a:pPr indent="0" marL="0">
-                        <a:buNone/>
-                      </a:pPr>
-                      <a:r>
-                        <a:rPr lang="en-US" sz="1200" dirty="0">
-                          <a:solidFill>
-                            <a:srgbClr val="263538"/>
-                          </a:solidFill>
-                          <a:latin typeface="Arial" pitchFamily="34" charset="0"/>
-                          <a:ea typeface="Arial" pitchFamily="34" charset="-122"/>
-                          <a:cs typeface="Arial" pitchFamily="34" charset="-120"/>
-                        </a:rPr>
-                        <a:t>очень высокий уровень</a:t>
-                      </a:r>
-                      <a:endParaRPr lang="en-US" sz="1200" dirty="0">
-                        <a:latin typeface="Arial" charset="0"/>
-                        <a:ea typeface="Arial" charset="0"/>
-                        <a:cs typeface="Arial" charset="0"/>
-                      </a:endParaRPr>
-                    </a:p>
-                  </a:txBody>
-                  <a:tcPr marL="73152" marR="73152" marT="73152" marB="73152" anchor="mid">
-                    <a:lnL w="12700" cap="flat" cmpd="sng" algn="ctr">
-                      <a:solidFill>
-                        <a:srgbClr val="D7E4E1"/>
-                      </a:solidFill>
-                      <a:prstDash val="solid"/>
-                      <a:round/>
-                      <a:headEnd type="none" w="med" len="med"/>
-                      <a:tailEnd type="none" w="med" len="med"/>
-                    </a:lnL>
-                    <a:lnR w="12700" cap="flat" cmpd="sng" algn="ctr">
-                      <a:solidFill>
-                        <a:srgbClr val="D7E4E1"/>
-                      </a:solidFill>
-                      <a:prstDash val="solid"/>
-                      <a:round/>
-                      <a:headEnd type="none" w="med" len="med"/>
-                      <a:tailEnd type="none" w="med" len="med"/>
-                    </a:lnR>
-                    <a:lnT w="12700" cap="flat" cmpd="sng" algn="ctr">
-                      <a:solidFill>
-                        <a:srgbClr val="D7E4E1"/>
-                      </a:solidFill>
-                      <a:prstDash val="solid"/>
-                      <a:round/>
-                      <a:headEnd type="none" w="med" len="med"/>
-                      <a:tailEnd type="none" w="med" len="med"/>
-                    </a:lnT>
-                    <a:lnB w="12700" cap="flat" cmpd="sng" algn="ctr">
-                      <a:solidFill>
-                        <a:srgbClr val="D7E4E1"/>
-                      </a:solidFill>
-                      <a:prstDash val="solid"/>
-                      <a:round/>
-                      <a:headEnd type="none" w="med" len="med"/>
-                      <a:tailEnd type="none" w="med" len="med"/>
-                    </a:lnB>
-                    <a:solidFill>
-                      <a:srgbClr val="FFFFFF"/>
-                    </a:solidFill>
-                  </a:tcPr>
-                </a:tc>
-              </a:tr>
-              <a:tr h="548640">
-                <a:tc>
-                  <a:txBody>
-                    <a:bodyPr/>
-                    <a:lstStyle/>
-                    <a:p>
-                      <a:pPr indent="0" marL="0">
-                        <a:buNone/>
-                      </a:pPr>
-                      <a:r>
-                        <a:rPr lang="en-US" sz="1200" dirty="0">
-                          <a:solidFill>
-                            <a:srgbClr val="263538"/>
-                          </a:solidFill>
-                          <a:latin typeface="Arial" pitchFamily="34" charset="0"/>
-                          <a:ea typeface="Arial" pitchFamily="34" charset="-122"/>
-                          <a:cs typeface="Arial" pitchFamily="34" charset="-120"/>
-                        </a:rPr>
-                        <a:t>2</a:t>
-                      </a:r>
-                      <a:endParaRPr lang="en-US" sz="1200" dirty="0">
-                        <a:latin typeface="Arial" charset="0"/>
-                        <a:ea typeface="Arial" charset="0"/>
-                        <a:cs typeface="Arial" charset="0"/>
-                      </a:endParaRPr>
-                    </a:p>
-                  </a:txBody>
-                  <a:tcPr marL="73152" marR="73152" marT="73152" marB="73152" anchor="mid">
-                    <a:lnL w="12700" cap="flat" cmpd="sng" algn="ctr">
-                      <a:solidFill>
-                        <a:srgbClr val="D7E4E1"/>
-                      </a:solidFill>
-                      <a:prstDash val="solid"/>
-                      <a:round/>
-                      <a:headEnd type="none" w="med" len="med"/>
-                      <a:tailEnd type="none" w="med" len="med"/>
-                    </a:lnL>
-                    <a:lnR w="12700" cap="flat" cmpd="sng" algn="ctr">
-                      <a:solidFill>
-                        <a:srgbClr val="D7E4E1"/>
-                      </a:solidFill>
-                      <a:prstDash val="solid"/>
-                      <a:round/>
-                      <a:headEnd type="none" w="med" len="med"/>
-                      <a:tailEnd type="none" w="med" len="med"/>
-                    </a:lnR>
-                    <a:lnT w="12700" cap="flat" cmpd="sng" algn="ctr">
-                      <a:solidFill>
-                        <a:srgbClr val="D7E4E1"/>
-                      </a:solidFill>
-                      <a:prstDash val="solid"/>
-                      <a:round/>
-                      <a:headEnd type="none" w="med" len="med"/>
-                      <a:tailEnd type="none" w="med" len="med"/>
-                    </a:lnT>
-                    <a:lnB w="12700" cap="flat" cmpd="sng" algn="ctr">
-                      <a:solidFill>
-                        <a:srgbClr val="D7E4E1"/>
-                      </a:solidFill>
-                      <a:prstDash val="solid"/>
-                      <a:round/>
-                      <a:headEnd type="none" w="med" len="med"/>
-                      <a:tailEnd type="none" w="med" len="med"/>
-                    </a:lnB>
-                    <a:solidFill>
-                      <a:srgbClr val="FFFFFF"/>
-                    </a:solidFill>
-                  </a:tcPr>
-                </a:tc>
-                <a:tc>
-                  <a:txBody>
-                    <a:bodyPr/>
-                    <a:lstStyle/>
-                    <a:p>
-                      <a:pPr indent="0" marL="0">
-                        <a:buNone/>
-                      </a:pPr>
-                      <a:r>
-                        <a:rPr lang="en-US" sz="1200" dirty="0">
-                          <a:solidFill>
-                            <a:srgbClr val="263538"/>
-                          </a:solidFill>
-                          <a:latin typeface="Arial" pitchFamily="34" charset="0"/>
-                          <a:ea typeface="Arial" pitchFamily="34" charset="-122"/>
-                          <a:cs typeface="Arial" pitchFamily="34" charset="-120"/>
-                        </a:rPr>
-                        <a:t>26</a:t>
-                      </a:r>
-                      <a:endParaRPr lang="en-US" sz="1200" dirty="0">
-                        <a:latin typeface="Arial" charset="0"/>
-                        <a:ea typeface="Arial" charset="0"/>
-                        <a:cs typeface="Arial" charset="0"/>
-                      </a:endParaRPr>
-                    </a:p>
-                  </a:txBody>
-                  <a:tcPr marL="73152" marR="73152" marT="73152" marB="73152" anchor="mid">
-                    <a:lnL w="12700" cap="flat" cmpd="sng" algn="ctr">
-                      <a:solidFill>
-                        <a:srgbClr val="D7E4E1"/>
-                      </a:solidFill>
-                      <a:prstDash val="solid"/>
-                      <a:round/>
-                      <a:headEnd type="none" w="med" len="med"/>
-                      <a:tailEnd type="none" w="med" len="med"/>
-                    </a:lnL>
-                    <a:lnR w="12700" cap="flat" cmpd="sng" algn="ctr">
-                      <a:solidFill>
-                        <a:srgbClr val="D7E4E1"/>
-                      </a:solidFill>
-                      <a:prstDash val="solid"/>
-                      <a:round/>
-                      <a:headEnd type="none" w="med" len="med"/>
-                      <a:tailEnd type="none" w="med" len="med"/>
-                    </a:lnR>
-                    <a:lnT w="12700" cap="flat" cmpd="sng" algn="ctr">
-                      <a:solidFill>
-                        <a:srgbClr val="D7E4E1"/>
-                      </a:solidFill>
-                      <a:prstDash val="solid"/>
-                      <a:round/>
-                      <a:headEnd type="none" w="med" len="med"/>
-                      <a:tailEnd type="none" w="med" len="med"/>
-                    </a:lnT>
-                    <a:lnB w="12700" cap="flat" cmpd="sng" algn="ctr">
-                      <a:solidFill>
-                        <a:srgbClr val="D7E4E1"/>
-                      </a:solidFill>
-                      <a:prstDash val="solid"/>
-                      <a:round/>
-                      <a:headEnd type="none" w="med" len="med"/>
-                      <a:tailEnd type="none" w="med" len="med"/>
-                    </a:lnB>
-                    <a:solidFill>
-                      <a:srgbClr val="FFFFFF"/>
-                    </a:solidFill>
-                  </a:tcPr>
-                </a:tc>
-                <a:tc>
-                  <a:txBody>
-                    <a:bodyPr/>
-                    <a:lstStyle/>
-                    <a:p>
-                      <a:pPr indent="0" marL="0">
-                        <a:buNone/>
-                      </a:pPr>
-                      <a:r>
-                        <a:rPr lang="en-US" sz="1200" dirty="0">
-                          <a:solidFill>
-                            <a:srgbClr val="263538"/>
-                          </a:solidFill>
-                          <a:latin typeface="Arial" pitchFamily="34" charset="0"/>
-                          <a:ea typeface="Arial" pitchFamily="34" charset="-122"/>
-                          <a:cs typeface="Arial" pitchFamily="34" charset="-120"/>
-                        </a:rPr>
-                        <a:t>высокий уровень</a:t>
-                      </a:r>
-                      <a:endParaRPr lang="en-US" sz="1200" dirty="0">
-                        <a:latin typeface="Arial" charset="0"/>
-                        <a:ea typeface="Arial" charset="0"/>
-                        <a:cs typeface="Arial" charset="0"/>
-                      </a:endParaRPr>
-                    </a:p>
-                  </a:txBody>
-                  <a:tcPr marL="73152" marR="73152" marT="73152" marB="73152" anchor="mid">
-                    <a:lnL w="12700" cap="flat" cmpd="sng" algn="ctr">
-                      <a:solidFill>
-                        <a:srgbClr val="D7E4E1"/>
-                      </a:solidFill>
-                      <a:prstDash val="solid"/>
-                      <a:round/>
-                      <a:headEnd type="none" w="med" len="med"/>
-                      <a:tailEnd type="none" w="med" len="med"/>
-                    </a:lnL>
-                    <a:lnR w="12700" cap="flat" cmpd="sng" algn="ctr">
-                      <a:solidFill>
-                        <a:srgbClr val="D7E4E1"/>
-                      </a:solidFill>
-                      <a:prstDash val="solid"/>
-                      <a:round/>
-                      <a:headEnd type="none" w="med" len="med"/>
-                      <a:tailEnd type="none" w="med" len="med"/>
-                    </a:lnR>
-                    <a:lnT w="12700" cap="flat" cmpd="sng" algn="ctr">
-                      <a:solidFill>
-                        <a:srgbClr val="D7E4E1"/>
-                      </a:solidFill>
-                      <a:prstDash val="solid"/>
-                      <a:round/>
-                      <a:headEnd type="none" w="med" len="med"/>
-                      <a:tailEnd type="none" w="med" len="med"/>
-                    </a:lnT>
-                    <a:lnB w="12700" cap="flat" cmpd="sng" algn="ctr">
-                      <a:solidFill>
-                        <a:srgbClr val="D7E4E1"/>
-                      </a:solidFill>
-                      <a:prstDash val="solid"/>
-                      <a:round/>
-                      <a:headEnd type="none" w="med" len="med"/>
-                      <a:tailEnd type="none" w="med" len="med"/>
-                    </a:lnB>
-                    <a:solidFill>
-                      <a:srgbClr val="FFFFFF"/>
-                    </a:solidFill>
-                  </a:tcPr>
-                </a:tc>
-              </a:tr>
-              <a:tr h="548640">
-                <a:tc>
-                  <a:txBody>
-                    <a:bodyPr/>
-                    <a:lstStyle/>
-                    <a:p>
-                      <a:pPr indent="0" marL="0">
-                        <a:buNone/>
-                      </a:pPr>
-                      <a:r>
-                        <a:rPr lang="en-US" sz="1200" dirty="0">
-                          <a:solidFill>
-                            <a:srgbClr val="263538"/>
-                          </a:solidFill>
-                          <a:latin typeface="Arial" pitchFamily="34" charset="0"/>
-                          <a:ea typeface="Arial" pitchFamily="34" charset="-122"/>
-                          <a:cs typeface="Arial" pitchFamily="34" charset="-120"/>
-                        </a:rPr>
-                        <a:t>3</a:t>
-                      </a:r>
-                      <a:endParaRPr lang="en-US" sz="1200" dirty="0">
-                        <a:latin typeface="Arial" charset="0"/>
-                        <a:ea typeface="Arial" charset="0"/>
-                        <a:cs typeface="Arial" charset="0"/>
-                      </a:endParaRPr>
-                    </a:p>
-                  </a:txBody>
-                  <a:tcPr marL="73152" marR="73152" marT="73152" marB="73152" anchor="mid">
-                    <a:lnL w="12700" cap="flat" cmpd="sng" algn="ctr">
-                      <a:solidFill>
-                        <a:srgbClr val="D7E4E1"/>
-                      </a:solidFill>
-                      <a:prstDash val="solid"/>
-                      <a:round/>
-                      <a:headEnd type="none" w="med" len="med"/>
-                      <a:tailEnd type="none" w="med" len="med"/>
-                    </a:lnL>
-                    <a:lnR w="12700" cap="flat" cmpd="sng" algn="ctr">
-                      <a:solidFill>
-                        <a:srgbClr val="D7E4E1"/>
-                      </a:solidFill>
-                      <a:prstDash val="solid"/>
-                      <a:round/>
-                      <a:headEnd type="none" w="med" len="med"/>
-                      <a:tailEnd type="none" w="med" len="med"/>
-                    </a:lnR>
-                    <a:lnT w="12700" cap="flat" cmpd="sng" algn="ctr">
-                      <a:solidFill>
-                        <a:srgbClr val="D7E4E1"/>
-                      </a:solidFill>
-                      <a:prstDash val="solid"/>
-                      <a:round/>
-                      <a:headEnd type="none" w="med" len="med"/>
-                      <a:tailEnd type="none" w="med" len="med"/>
-                    </a:lnT>
-                    <a:lnB w="12700" cap="flat" cmpd="sng" algn="ctr">
-                      <a:solidFill>
-                        <a:srgbClr val="D7E4E1"/>
-                      </a:solidFill>
-                      <a:prstDash val="solid"/>
-                      <a:round/>
-                      <a:headEnd type="none" w="med" len="med"/>
-                      <a:tailEnd type="none" w="med" len="med"/>
-                    </a:lnB>
-                    <a:solidFill>
-                      <a:srgbClr val="FFFFFF"/>
-                    </a:solidFill>
-                  </a:tcPr>
-                </a:tc>
-                <a:tc>
-                  <a:txBody>
-                    <a:bodyPr/>
-                    <a:lstStyle/>
-                    <a:p>
-                      <a:pPr indent="0" marL="0">
-                        <a:buNone/>
-                      </a:pPr>
-                      <a:r>
-                        <a:rPr lang="en-US" sz="1200" dirty="0">
-                          <a:solidFill>
-                            <a:srgbClr val="263538"/>
-                          </a:solidFill>
-                          <a:latin typeface="Arial" pitchFamily="34" charset="0"/>
-                          <a:ea typeface="Arial" pitchFamily="34" charset="-122"/>
-                          <a:cs typeface="Arial" pitchFamily="34" charset="-120"/>
-                        </a:rPr>
-                        <a:t>7</a:t>
-                      </a:r>
-                      <a:endParaRPr lang="en-US" sz="1200" dirty="0">
-                        <a:latin typeface="Arial" charset="0"/>
-                        <a:ea typeface="Arial" charset="0"/>
-                        <a:cs typeface="Arial" charset="0"/>
-                      </a:endParaRPr>
-                    </a:p>
-                  </a:txBody>
-                  <a:tcPr marL="73152" marR="73152" marT="73152" marB="73152" anchor="mid">
-                    <a:lnL w="12700" cap="flat" cmpd="sng" algn="ctr">
-                      <a:solidFill>
-                        <a:srgbClr val="D7E4E1"/>
-                      </a:solidFill>
-                      <a:prstDash val="solid"/>
-                      <a:round/>
-                      <a:headEnd type="none" w="med" len="med"/>
-                      <a:tailEnd type="none" w="med" len="med"/>
-                    </a:lnL>
-                    <a:lnR w="12700" cap="flat" cmpd="sng" algn="ctr">
-                      <a:solidFill>
-                        <a:srgbClr val="D7E4E1"/>
-                      </a:solidFill>
-                      <a:prstDash val="solid"/>
-                      <a:round/>
-                      <a:headEnd type="none" w="med" len="med"/>
-                      <a:tailEnd type="none" w="med" len="med"/>
-                    </a:lnR>
-                    <a:lnT w="12700" cap="flat" cmpd="sng" algn="ctr">
-                      <a:solidFill>
-                        <a:srgbClr val="D7E4E1"/>
-                      </a:solidFill>
-                      <a:prstDash val="solid"/>
-                      <a:round/>
-                      <a:headEnd type="none" w="med" len="med"/>
-                      <a:tailEnd type="none" w="med" len="med"/>
-                    </a:lnT>
-                    <a:lnB w="12700" cap="flat" cmpd="sng" algn="ctr">
-                      <a:solidFill>
-                        <a:srgbClr val="D7E4E1"/>
-                      </a:solidFill>
-                      <a:prstDash val="solid"/>
-                      <a:round/>
-                      <a:headEnd type="none" w="med" len="med"/>
-                      <a:tailEnd type="none" w="med" len="med"/>
-                    </a:lnB>
-                    <a:solidFill>
-                      <a:srgbClr val="FFFFFF"/>
-                    </a:solidFill>
-                  </a:tcPr>
-                </a:tc>
-                <a:tc>
-                  <a:txBody>
-                    <a:bodyPr/>
-                    <a:lstStyle/>
-                    <a:p>
-                      <a:pPr indent="0" marL="0">
-                        <a:buNone/>
-                      </a:pPr>
-                      <a:r>
-                        <a:rPr lang="en-US" sz="1200" dirty="0">
-                          <a:solidFill>
-                            <a:srgbClr val="263538"/>
-                          </a:solidFill>
-                          <a:latin typeface="Arial" pitchFamily="34" charset="0"/>
-                          <a:ea typeface="Arial" pitchFamily="34" charset="-122"/>
-                          <a:cs typeface="Arial" pitchFamily="34" charset="-120"/>
-                        </a:rPr>
-                        <a:t>средний с тенденцией к низкому</a:t>
-                      </a:r>
-                      <a:endParaRPr lang="en-US" sz="1200" dirty="0">
-                        <a:latin typeface="Arial" charset="0"/>
-                        <a:ea typeface="Arial" charset="0"/>
-                        <a:cs typeface="Arial" charset="0"/>
-                      </a:endParaRPr>
-                    </a:p>
-                  </a:txBody>
-                  <a:tcPr marL="73152" marR="73152" marT="73152" marB="73152" anchor="mid">
-                    <a:lnL w="12700" cap="flat" cmpd="sng" algn="ctr">
-                      <a:solidFill>
-                        <a:srgbClr val="D7E4E1"/>
-                      </a:solidFill>
-                      <a:prstDash val="solid"/>
-                      <a:round/>
-                      <a:headEnd type="none" w="med" len="med"/>
-                      <a:tailEnd type="none" w="med" len="med"/>
-                    </a:lnL>
-                    <a:lnR w="12700" cap="flat" cmpd="sng" algn="ctr">
-                      <a:solidFill>
-                        <a:srgbClr val="D7E4E1"/>
-                      </a:solidFill>
-                      <a:prstDash val="solid"/>
-                      <a:round/>
-                      <a:headEnd type="none" w="med" len="med"/>
-                      <a:tailEnd type="none" w="med" len="med"/>
-                    </a:lnR>
-                    <a:lnT w="12700" cap="flat" cmpd="sng" algn="ctr">
-                      <a:solidFill>
-                        <a:srgbClr val="D7E4E1"/>
-                      </a:solidFill>
-                      <a:prstDash val="solid"/>
-                      <a:round/>
-                      <a:headEnd type="none" w="med" len="med"/>
-                      <a:tailEnd type="none" w="med" len="med"/>
-                    </a:lnT>
-                    <a:lnB w="12700" cap="flat" cmpd="sng" algn="ctr">
-                      <a:solidFill>
-                        <a:srgbClr val="D7E4E1"/>
-                      </a:solidFill>
-                      <a:prstDash val="solid"/>
-                      <a:round/>
-                      <a:headEnd type="none" w="med" len="med"/>
-                      <a:tailEnd type="none" w="med" len="med"/>
-                    </a:lnB>
-                    <a:solidFill>
-                      <a:srgbClr val="FFFFFF"/>
-                    </a:solidFill>
-                  </a:tcPr>
-                </a:tc>
-              </a:tr>
-            </a:tbl>
-          </a:graphicData>
-        </a:graphic>
-      </p:graphicFrame>
-      <p:graphicFrame>
-        <p:nvGraphicFramePr>
-          <p:cNvPr id="5" name="Chart 0" descr=""/>
-          <p:cNvGraphicFramePr/>
-          <p:nvPr/>
-        </p:nvGraphicFramePr>
-        <p:xfrm>
-          <a:off x="7818120" y="1325880"/>
-          <a:ext cx="3383280" cy="2788920"/>
-        </p:xfrm>
-        <a:graphic xmlns:a="http://schemas.openxmlformats.org/drawingml/2006/main">
-          <a:graphicData uri="http://schemas.openxmlformats.org/drawingml/2006/chart">
-            <c:chart xmlns:c="http://schemas.openxmlformats.org/drawingml/2006/chart" r:id="rId1"/>
-          </a:graphicData>
-        </a:graphic>
-      </p:graphicFrame>
-      <p:sp>
-        <p:nvSpPr>
-          <p:cNvPr id="6" name="Shape 2"/>
-          <p:cNvSpPr/>
-          <p:nvPr/>
-        </p:nvSpPr>
-        <p:spPr>
-          <a:xfrm>
-            <a:off x="502920" y="6419088"/>
-            <a:ext cx="11155680" cy="0"/>
-          </a:xfrm>
-          <a:prstGeom prst="line">
-            <a:avLst/>
-          </a:prstGeom>
-          <a:noFill/>
-          <a:ln w="12700">
-            <a:solidFill>
-              <a:srgbClr val="D7E4E1"/>
-            </a:solidFill>
-            <a:prstDash val="solid"/>
-          </a:ln>
-        </p:spPr>
-      </p:sp>
-      <p:sp>
-        <p:nvSpPr>
-          <p:cNvPr id="7" name="Text 3"/>
-          <p:cNvSpPr/>
-          <p:nvPr/>
-        </p:nvSpPr>
-        <p:spPr>
-          <a:xfrm>
-            <a:off x="548640" y="6473952"/>
-            <a:ext cx="3931920" cy="201168"/>
-          </a:xfrm>
-          <a:prstGeom prst="rect">
-            <a:avLst/>
-          </a:prstGeom>
-          <a:noFill/>
-          <a:ln/>
-        </p:spPr>
-        <p:txBody>
-          <a:bodyPr wrap="square" rtlCol="0" anchor="ctr"/>
-          <a:lstStyle/>
-          <a:p>
-            <a:pPr indent="0" marL="0">
-              <a:buNone/>
-            </a:pPr>
-            <a:r>
-              <a:rPr lang="en-US" sz="850" dirty="0">
-                <a:solidFill>
-                  <a:srgbClr val="66797C"/>
-                </a:solidFill>
-                <a:latin typeface="Arial" pitchFamily="34" charset="0"/>
-                <a:ea typeface="Arial" pitchFamily="34" charset="-122"/>
-                <a:cs typeface="Arial" pitchFamily="34" charset="-120"/>
-              </a:rPr>
-              <a:t>[ФИО] | [Группа]</a:t>
-            </a:r>
-            <a:endParaRPr lang="en-US" sz="850" dirty="0"/>
-          </a:p>
-        </p:txBody>
-      </p:sp>
-      <p:sp>
-        <p:nvSpPr>
-          <p:cNvPr id="8" name="Text 4"/>
-          <p:cNvSpPr/>
-          <p:nvPr/>
-        </p:nvSpPr>
-        <p:spPr>
-          <a:xfrm>
-            <a:off x="11201400" y="6473952"/>
-            <a:ext cx="411480" cy="201168"/>
-          </a:xfrm>
-          <a:prstGeom prst="rect">
-            <a:avLst/>
-          </a:prstGeom>
-          <a:noFill/>
-          <a:ln/>
-        </p:spPr>
-        <p:txBody>
-          <a:bodyPr wrap="square" rtlCol="0" anchor="ctr"/>
-          <a:lstStyle/>
-          <a:p>
-            <a:pPr algn="r" indent="0" marL="0">
-              <a:buNone/>
-            </a:pPr>
-            <a:r>
-              <a:rPr lang="en-US" sz="850" dirty="0">
-                <a:solidFill>
-                  <a:srgbClr val="66797C"/>
-                </a:solidFill>
-                <a:latin typeface="Arial" pitchFamily="34" charset="0"/>
-                <a:ea typeface="Arial" pitchFamily="34" charset="-122"/>
-                <a:cs typeface="Arial" pitchFamily="34" charset="-120"/>
-              </a:rPr>
-              <a:t>5</a:t>
-            </a:r>
-            <a:endParaRPr lang="en-US" sz="850" dirty="0"/>
-          </a:p>
-        </p:txBody>
-      </p:sp>
-    </p:spTree>
-  </p:cSld>
-  <p:clrMapOvr>
-    <a:masterClrMapping/>
-  </p:clrMapOvr>
-</p:sld>
+<ns0:sld xmlns:ns0="http://schemas.openxmlformats.org/presentationml/2006/main" xmlns:ns1="http://schemas.openxmlformats.org/drawingml/2006/main" xmlns:ns2="http://schemas.microsoft.com/office/powerpoint/2010/main" xmlns:ns3="http://schemas.openxmlformats.org/drawingml/2006/chart" xmlns:ns4="http://schemas.openxmlformats.org/officeDocument/2006/relationships">
+  <ns0:cSld name="Slide 5">
+    <ns0:spTree>
+      <ns0:nvGrpSpPr>
+        <ns0:cNvPr id="1" name=""/>
+        <ns0:cNvGrpSpPr/>
+        <ns0:nvPr/>
+      </ns0:nvGrpSpPr>
+      <ns0:grpSpPr>
+        <ns1:xfrm>
+          <ns1:off x="0" y="0"/>
+          <ns1:ext cx="0" cy="0"/>
+          <ns1:chOff x="0" y="0"/>
+          <ns1:chExt cx="0" cy="0"/>
+        </ns1:xfrm>
+      </ns0:grpSpPr>
+      <ns0:sp>
+        <ns0:nvSpPr>
+          <ns0:cNvPr id="2" name="Text 0"/>
+          <ns0:cNvSpPr/>
+          <ns0:nvPr/>
+        </ns0:nvSpPr>
+        <ns0:spPr>
+          <ns1:xfrm>
+            <ns1:off x="640080" y="502920"/>
+            <ns1:ext cx="7955280" cy="502920"/>
+          </ns1:xfrm>
+          <ns1:prstGeom prst="rect">
+            <ns1:avLst/>
+          </ns1:prstGeom>
+          <ns1:noFill/>
+          <ns1:ln/>
+        </ns0:spPr>
+        <ns0:txBody>
+          <ns1:bodyPr wrap="square" lIns="254" tIns="254" rIns="254" bIns="254" rtlCol="0" anchor="ctr">
+            <ns1:normAutofit/>
+          </ns1:bodyPr>
+          <ns1:lstStyle/>
+          <ns1:p>
+            <ns1:pPr indent="0" marL="0">
+              <ns1:buNone/>
+            </ns1:pPr>
+            <ns1:r>
+              <ns1:rPr lang="en-US" sz="2500" b="1" dirty="0">
+                <ns1:solidFill>
+                  <ns1:srgbClr val="2F686D"/>
+                </ns1:solidFill>
+                <ns1:latin typeface="Arial" pitchFamily="34" charset="0"/>
+                <ns1:ea typeface="Arial" pitchFamily="34" charset="-122"/>
+                <ns1:cs typeface="Arial" pitchFamily="34" charset="-120"/>
+              </ns1:rPr>
+              <ns1:t>Результаты теста тревожности</ns1:t>
+            </ns1:r>
+            <ns1:endParaRPr lang="en-US" sz="2500" dirty="0"/>
+          </ns1:p>
+        </ns0:txBody>
+      </ns0:sp>
+      <ns0:sp>
+        <ns0:nvSpPr>
+          <ns0:cNvPr id="3" name="Text 1"/>
+          <ns0:cNvSpPr/>
+          <ns0:nvPr/>
+        </ns0:nvSpPr>
+        <ns0:spPr>
+          <ns1:xfrm>
+            <ns1:off x="658368" y="1024128"/>
+            <ns1:ext cx="7498080" cy="256032"/>
+          </ns1:xfrm>
+          <ns1:prstGeom prst="rect">
+            <ns1:avLst/>
+          </ns1:prstGeom>
+          <ns1:noFill/>
+          <ns1:ln/>
+        </ns0:spPr>
+        <ns0:txBody>
+          <ns1:bodyPr wrap="square" lIns="254" tIns="254" rIns="254" bIns="254" rtlCol="0" anchor="ctr"/>
+          <ns1:lstStyle/>
+          <ns1:p>
+            <ns1:pPr indent="0" marL="0">
+              <ns1:buNone/>
+            </ns1:pPr>
+            <ns1:r>
+              <ns1:rPr lang="en-US" sz="1100" dirty="0">
+                <ns1:solidFill>
+                  <ns1:srgbClr val="5C6E70"/>
+                </ns1:solidFill>
+                <ns1:latin typeface="Arial" pitchFamily="34" charset="0"/>
+                <ns1:ea typeface="Arial" pitchFamily="34" charset="-122"/>
+                <ns1:cs typeface="Arial" pitchFamily="34" charset="-120"/>
+              </ns1:rPr>
+              <ns1:t>Реальные ответы Google Forms, 3 респондента</ns1:t>
+            </ns1:r>
+            <ns1:endParaRPr lang="en-US" sz="1100" dirty="0"/>
+          </ns1:p>
+        </ns0:txBody>
+      </ns0:sp>
+      <ns0:graphicFrame>
+        <ns0:nvGraphicFramePr>
+          <ns0:cNvPr id="6" name="Table 0"/>
+          <ns0:cNvGraphicFramePr>
+            <ns1:graphicFrameLocks noGrp="1"/>
+          </ns0:cNvGraphicFramePr>
+          <ns0:nvPr>
+            <ns0:extLst>
+              <ns0:ext uri="{D42A27DB-BD31-4B8C-83A1-F6EECF244321}">
+                <ns2:modId val="1579011935"/>
+              </ns0:ext>
+            </ns0:extLst>
+          </ns0:nvPr>
+        </ns0:nvGraphicFramePr>
+        <ns0:xfrm>
+          <ns1:off x="749808" y="1444752"/>
+          <ns1:ext cx="6675120" cy="2194560"/>
+        </ns0:xfrm>
+        <ns1:graphic>
+          <ns1:graphicData uri="http://schemas.openxmlformats.org/drawingml/2006/table">
+            <ns1:tbl>
+              <ns1:tblPr/>
+              <ns1:tblGrid>
+                <ns1:gridCol w="1554480"/>
+                <ns1:gridCol w="1097280"/>
+                <ns1:gridCol w="4023360"/>
+              </ns1:tblGrid>
+              <ns1:tr h="548640">
+                <ns1:tc>
+                  <ns1:txBody>
+                    <ns1:bodyPr/>
+                    <ns1:lstStyle/>
+                    <ns1:p>
+                      <ns1:pPr indent="0" marL="0">
+                        <ns1:buNone/>
+                      </ns1:pPr>
+                      <ns1:r>
+                        <ns1:rPr lang="en-US" sz="1200" dirty="0">
+                          <ns1:solidFill>
+                            <ns1:srgbClr val="263538"/>
+                          </ns1:solidFill>
+                          <ns1:latin typeface="Arial" pitchFamily="34" charset="0"/>
+                          <ns1:ea typeface="Arial" pitchFamily="34" charset="-122"/>
+                          <ns1:cs typeface="Arial" pitchFamily="34" charset="-120"/>
+                        </ns1:rPr>
+                        <ns1:t>Респондент</ns1:t>
+                      </ns1:r>
+                      <ns1:endParaRPr lang="en-US" sz="1200" dirty="0">
+                        <ns1:latin typeface="Arial" charset="0"/>
+                        <ns1:ea typeface="Arial" charset="0"/>
+                        <ns1:cs typeface="Arial" charset="0"/>
+                      </ns1:endParaRPr>
+                    </ns1:p>
+                  </ns1:txBody>
+                  <ns1:tcPr marL="73152" marR="73152" marT="73152" marB="73152" anchor="mid">
+                    <ns1:lnL w="12700" cap="flat" cmpd="sng" algn="ctr">
+                      <ns1:solidFill>
+                        <ns1:srgbClr val="D7E4E1"/>
+                      </ns1:solidFill>
+                      <ns1:prstDash val="solid"/>
+                      <ns1:round/>
+                      <ns1:headEnd type="none" w="med" len="med"/>
+                      <ns1:tailEnd type="none" w="med" len="med"/>
+                    </ns1:lnL>
+                    <ns1:lnR w="12700" cap="flat" cmpd="sng" algn="ctr">
+                      <ns1:solidFill>
+                        <ns1:srgbClr val="D7E4E1"/>
+                      </ns1:solidFill>
+                      <ns1:prstDash val="solid"/>
+                      <ns1:round/>
+                      <ns1:headEnd type="none" w="med" len="med"/>
+                      <ns1:tailEnd type="none" w="med" len="med"/>
+                    </ns1:lnR>
+                    <ns1:lnT w="12700" cap="flat" cmpd="sng" algn="ctr">
+                      <ns1:solidFill>
+                        <ns1:srgbClr val="D7E4E1"/>
+                      </ns1:solidFill>
+                      <ns1:prstDash val="solid"/>
+                      <ns1:round/>
+                      <ns1:headEnd type="none" w="med" len="med"/>
+                      <ns1:tailEnd type="none" w="med" len="med"/>
+                    </ns1:lnT>
+                    <ns1:lnB w="12700" cap="flat" cmpd="sng" algn="ctr">
+                      <ns1:solidFill>
+                        <ns1:srgbClr val="D7E4E1"/>
+                      </ns1:solidFill>
+                      <ns1:prstDash val="solid"/>
+                      <ns1:round/>
+                      <ns1:headEnd type="none" w="med" len="med"/>
+                      <ns1:tailEnd type="none" w="med" len="med"/>
+                    </ns1:lnB>
+                    <ns1:solidFill>
+                      <ns1:srgbClr val="FFFFFF"/>
+                    </ns1:solidFill>
+                  </ns1:tcPr>
+                </ns1:tc>
+                <ns1:tc>
+                  <ns1:txBody>
+                    <ns1:bodyPr/>
+                    <ns1:lstStyle/>
+                    <ns1:p>
+                      <ns1:pPr indent="0" marL="0">
+                        <ns1:buNone/>
+                      </ns1:pPr>
+                      <ns1:r>
+                        <ns1:rPr lang="en-US" sz="1200" dirty="0">
+                          <ns1:solidFill>
+                            <ns1:srgbClr val="263538"/>
+                          </ns1:solidFill>
+                          <ns1:latin typeface="Arial" pitchFamily="34" charset="0"/>
+                          <ns1:ea typeface="Arial" pitchFamily="34" charset="-122"/>
+                          <ns1:cs typeface="Arial" pitchFamily="34" charset="-120"/>
+                        </ns1:rPr>
+                        <ns1:t>Баллы</ns1:t>
+                      </ns1:r>
+                      <ns1:endParaRPr lang="en-US" sz="1200" dirty="0">
+                        <ns1:latin typeface="Arial" charset="0"/>
+                        <ns1:ea typeface="Arial" charset="0"/>
+                        <ns1:cs typeface="Arial" charset="0"/>
+                      </ns1:endParaRPr>
+                    </ns1:p>
+                  </ns1:txBody>
+                  <ns1:tcPr marL="73152" marR="73152" marT="73152" marB="73152" anchor="mid">
+                    <ns1:lnL w="12700" cap="flat" cmpd="sng" algn="ctr">
+                      <ns1:solidFill>
+                        <ns1:srgbClr val="D7E4E1"/>
+                      </ns1:solidFill>
+                      <ns1:prstDash val="solid"/>
+                      <ns1:round/>
+                      <ns1:headEnd type="none" w="med" len="med"/>
+                      <ns1:tailEnd type="none" w="med" len="med"/>
+                    </ns1:lnL>
+                    <ns1:lnR w="12700" cap="flat" cmpd="sng" algn="ctr">
+                      <ns1:solidFill>
+                        <ns1:srgbClr val="D7E4E1"/>
+                      </ns1:solidFill>
+                      <ns1:prstDash val="solid"/>
+                      <ns1:round/>
+                      <ns1:headEnd type="none" w="med" len="med"/>
+                      <ns1:tailEnd type="none" w="med" len="med"/>
+                    </ns1:lnR>
+                    <ns1:lnT w="12700" cap="flat" cmpd="sng" algn="ctr">
+                      <ns1:solidFill>
+                        <ns1:srgbClr val="D7E4E1"/>
+                      </ns1:solidFill>
+                      <ns1:prstDash val="solid"/>
+                      <ns1:round/>
+                      <ns1:headEnd type="none" w="med" len="med"/>
+                      <ns1:tailEnd type="none" w="med" len="med"/>
+                    </ns1:lnT>
+                    <ns1:lnB w="12700" cap="flat" cmpd="sng" algn="ctr">
+                      <ns1:solidFill>
+                        <ns1:srgbClr val="D7E4E1"/>
+                      </ns1:solidFill>
+                      <ns1:prstDash val="solid"/>
+                      <ns1:round/>
+                      <ns1:headEnd type="none" w="med" len="med"/>
+                      <ns1:tailEnd type="none" w="med" len="med"/>
+                    </ns1:lnB>
+                    <ns1:solidFill>
+                      <ns1:srgbClr val="FFFFFF"/>
+                    </ns1:solidFill>
+                  </ns1:tcPr>
+                </ns1:tc>
+                <ns1:tc>
+                  <ns1:txBody>
+                    <ns1:bodyPr/>
+                    <ns1:lstStyle/>
+                    <ns1:p>
+                      <ns1:pPr indent="0" marL="0">
+                        <ns1:buNone/>
+                      </ns1:pPr>
+                      <ns1:r>
+                        <ns1:rPr lang="en-US" sz="1200" dirty="0">
+                          <ns1:solidFill>
+                            <ns1:srgbClr val="263538"/>
+                          </ns1:solidFill>
+                          <ns1:latin typeface="Arial" pitchFamily="34" charset="0"/>
+                          <ns1:ea typeface="Arial" pitchFamily="34" charset="-122"/>
+                          <ns1:cs typeface="Arial" pitchFamily="34" charset="-120"/>
+                        </ns1:rPr>
+                        <ns1:t>Интерпретация</ns1:t>
+                      </ns1:r>
+                      <ns1:endParaRPr lang="en-US" sz="1200" dirty="0">
+                        <ns1:latin typeface="Arial" charset="0"/>
+                        <ns1:ea typeface="Arial" charset="0"/>
+                        <ns1:cs typeface="Arial" charset="0"/>
+                      </ns1:endParaRPr>
+                    </ns1:p>
+                  </ns1:txBody>
+                  <ns1:tcPr marL="73152" marR="73152" marT="73152" marB="73152" anchor="mid">
+                    <ns1:lnL w="12700" cap="flat" cmpd="sng" algn="ctr">
+                      <ns1:solidFill>
+                        <ns1:srgbClr val="D7E4E1"/>
+                      </ns1:solidFill>
+                      <ns1:prstDash val="solid"/>
+                      <ns1:round/>
+                      <ns1:headEnd type="none" w="med" len="med"/>
+                      <ns1:tailEnd type="none" w="med" len="med"/>
+                    </ns1:lnL>
+                    <ns1:lnR w="12700" cap="flat" cmpd="sng" algn="ctr">
+                      <ns1:solidFill>
+                        <ns1:srgbClr val="D7E4E1"/>
+                      </ns1:solidFill>
+                      <ns1:prstDash val="solid"/>
+                      <ns1:round/>
+                      <ns1:headEnd type="none" w="med" len="med"/>
+                      <ns1:tailEnd type="none" w="med" len="med"/>
+                    </ns1:lnR>
+                    <ns1:lnT w="12700" cap="flat" cmpd="sng" algn="ctr">
+                      <ns1:solidFill>
+                        <ns1:srgbClr val="D7E4E1"/>
+                      </ns1:solidFill>
+                      <ns1:prstDash val="solid"/>
+                      <ns1:round/>
+                      <ns1:headEnd type="none" w="med" len="med"/>
+                      <ns1:tailEnd type="none" w="med" len="med"/>
+                    </ns1:lnT>
+                    <ns1:lnB w="12700" cap="flat" cmpd="sng" algn="ctr">
+                      <ns1:solidFill>
+                        <ns1:srgbClr val="D7E4E1"/>
+                      </ns1:solidFill>
+                      <ns1:prstDash val="solid"/>
+                      <ns1:round/>
+                      <ns1:headEnd type="none" w="med" len="med"/>
+                      <ns1:tailEnd type="none" w="med" len="med"/>
+                    </ns1:lnB>
+                    <ns1:solidFill>
+                      <ns1:srgbClr val="FFFFFF"/>
+                    </ns1:solidFill>
+                  </ns1:tcPr>
+                </ns1:tc>
+              </ns1:tr>
+              <ns1:tr h="548640">
+                <ns1:tc>
+                  <ns1:txBody>
+                    <ns1:bodyPr/>
+                    <ns1:lstStyle/>
+                    <ns1:p>
+                      <ns1:pPr indent="0" marL="0">
+                        <ns1:buNone/>
+                      </ns1:pPr>
+                      <ns1:r>
+                        <ns1:rPr lang="en-US" sz="1200" dirty="0">
+                          <ns1:solidFill>
+                            <ns1:srgbClr val="263538"/>
+                          </ns1:solidFill>
+                          <ns1:latin typeface="Arial" pitchFamily="34" charset="0"/>
+                          <ns1:ea typeface="Arial" pitchFamily="34" charset="-122"/>
+                          <ns1:cs typeface="Arial" pitchFamily="34" charset="-120"/>
+                        </ns1:rPr>
+                        <ns1:t>1</ns1:t>
+                      </ns1:r>
+                      <ns1:endParaRPr lang="en-US" sz="1200" dirty="0">
+                        <ns1:latin typeface="Arial" charset="0"/>
+                        <ns1:ea typeface="Arial" charset="0"/>
+                        <ns1:cs typeface="Arial" charset="0"/>
+                      </ns1:endParaRPr>
+                    </ns1:p>
+                  </ns1:txBody>
+                  <ns1:tcPr marL="73152" marR="73152" marT="73152" marB="73152" anchor="mid">
+                    <ns1:lnL w="12700" cap="flat" cmpd="sng" algn="ctr">
+                      <ns1:solidFill>
+                        <ns1:srgbClr val="D7E4E1"/>
+                      </ns1:solidFill>
+                      <ns1:prstDash val="solid"/>
+                      <ns1:round/>
+                      <ns1:headEnd type="none" w="med" len="med"/>
+                      <ns1:tailEnd type="none" w="med" len="med"/>
+                    </ns1:lnL>
+                    <ns1:lnR w="12700" cap="flat" cmpd="sng" algn="ctr">
+                      <ns1:solidFill>
+                        <ns1:srgbClr val="D7E4E1"/>
+                      </ns1:solidFill>
+                      <ns1:prstDash val="solid"/>
+                      <ns1:round/>
+                      <ns1:headEnd type="none" w="med" len="med"/>
+                      <ns1:tailEnd type="none" w="med" len="med"/>
+                    </ns1:lnR>
+                    <ns1:lnT w="12700" cap="flat" cmpd="sng" algn="ctr">
+                      <ns1:solidFill>
+                        <ns1:srgbClr val="D7E4E1"/>
+                      </ns1:solidFill>
+                      <ns1:prstDash val="solid"/>
+                      <ns1:round/>
+                      <ns1:headEnd type="none" w="med" len="med"/>
+                      <ns1:tailEnd type="none" w="med" len="med"/>
+                    </ns1:lnT>
+                    <ns1:lnB w="12700" cap="flat" cmpd="sng" algn="ctr">
+                      <ns1:solidFill>
+                        <ns1:srgbClr val="D7E4E1"/>
+                      </ns1:solidFill>
+                      <ns1:prstDash val="solid"/>
+                      <ns1:round/>
+                      <ns1:headEnd type="none" w="med" len="med"/>
+                      <ns1:tailEnd type="none" w="med" len="med"/>
+                    </ns1:lnB>
+                    <ns1:solidFill>
+                      <ns1:srgbClr val="FFFFFF"/>
+                    </ns1:solidFill>
+                  </ns1:tcPr>
+                </ns1:tc>
+                <ns1:tc>
+                  <ns1:txBody>
+                    <ns1:bodyPr/>
+                    <ns1:lstStyle/>
+                    <ns1:p>
+                      <ns1:pPr indent="0" marL="0">
+                        <ns1:buNone/>
+                      </ns1:pPr>
+                      <ns1:r>
+                        <ns1:rPr lang="en-US" sz="1200" dirty="0">
+                          <ns1:solidFill>
+                            <ns1:srgbClr val="263538"/>
+                          </ns1:solidFill>
+                          <ns1:latin typeface="Arial" pitchFamily="34" charset="0"/>
+                          <ns1:ea typeface="Arial" pitchFamily="34" charset="-122"/>
+                          <ns1:cs typeface="Arial" pitchFamily="34" charset="-120"/>
+                        </ns1:rPr>
+                        <ns1:t>18</ns1:t>
+                      </ns1:r>
+                      <ns1:endParaRPr lang="en-US" sz="1200" dirty="0">
+                        <ns1:latin typeface="Arial" charset="0"/>
+                        <ns1:ea typeface="Arial" charset="0"/>
+                        <ns1:cs typeface="Arial" charset="0"/>
+                      </ns1:endParaRPr>
+                    </ns1:p>
+                  </ns1:txBody>
+                  <ns1:tcPr marL="73152" marR="73152" marT="73152" marB="73152" anchor="mid">
+                    <ns1:lnL w="12700" cap="flat" cmpd="sng" algn="ctr">
+                      <ns1:solidFill>
+                        <ns1:srgbClr val="D7E4E1"/>
+                      </ns1:solidFill>
+                      <ns1:prstDash val="solid"/>
+                      <ns1:round/>
+                      <ns1:headEnd type="none" w="med" len="med"/>
+                      <ns1:tailEnd type="none" w="med" len="med"/>
+                    </ns1:lnL>
+                    <ns1:lnR w="12700" cap="flat" cmpd="sng" algn="ctr">
+                      <ns1:solidFill>
+                        <ns1:srgbClr val="D7E4E1"/>
+                      </ns1:solidFill>
+                      <ns1:prstDash val="solid"/>
+                      <ns1:round/>
+                      <ns1:headEnd type="none" w="med" len="med"/>
+                      <ns1:tailEnd type="none" w="med" len="med"/>
+                    </ns1:lnR>
+                    <ns1:lnT w="12700" cap="flat" cmpd="sng" algn="ctr">
+                      <ns1:solidFill>
+                        <ns1:srgbClr val="D7E4E1"/>
+                      </ns1:solidFill>
+                      <ns1:prstDash val="solid"/>
+                      <ns1:round/>
+                      <ns1:headEnd type="none" w="med" len="med"/>
+                      <ns1:tailEnd type="none" w="med" len="med"/>
+                    </ns1:lnT>
+                    <ns1:lnB w="12700" cap="flat" cmpd="sng" algn="ctr">
+                      <ns1:solidFill>
+                        <ns1:srgbClr val="D7E4E1"/>
+                      </ns1:solidFill>
+                      <ns1:prstDash val="solid"/>
+                      <ns1:round/>
+                      <ns1:headEnd type="none" w="med" len="med"/>
+                      <ns1:tailEnd type="none" w="med" len="med"/>
+                    </ns1:lnB>
+                    <ns1:solidFill>
+                      <ns1:srgbClr val="FFFFFF"/>
+                    </ns1:solidFill>
+                  </ns1:tcPr>
+                </ns1:tc>
+                <ns1:tc>
+                  <ns1:txBody>
+                    <ns1:bodyPr/>
+                    <ns1:lstStyle/>
+                    <ns1:p>
+                      <ns1:pPr indent="0" marL="0">
+                        <ns1:buNone/>
+                      </ns1:pPr>
+                      <ns1:r>
+                        <ns1:rPr lang="en-US" sz="1200" dirty="0">
+                          <ns1:solidFill>
+                            <ns1:srgbClr val="263538"/>
+                          </ns1:solidFill>
+                          <ns1:latin typeface="Arial" pitchFamily="34" charset="0"/>
+                          <ns1:ea typeface="Arial" pitchFamily="34" charset="-122"/>
+                          <ns1:cs typeface="Arial" pitchFamily="34" charset="-120"/>
+                        </ns1:rPr>
+                        <ns1:t>средний уровень тревоги с тенденцией к высокому</ns1:t>
+                      </ns1:r>
+                      <ns1:endParaRPr lang="en-US" sz="1200" dirty="0">
+                        <ns1:latin typeface="Arial" charset="0"/>
+                        <ns1:ea typeface="Arial" charset="0"/>
+                        <ns1:cs typeface="Arial" charset="0"/>
+                      </ns1:endParaRPr>
+                    </ns1:p>
+                  </ns1:txBody>
+                  <ns1:tcPr marL="73152" marR="73152" marT="73152" marB="73152" anchor="mid">
+                    <ns1:lnL w="12700" cap="flat" cmpd="sng" algn="ctr">
+                      <ns1:solidFill>
+                        <ns1:srgbClr val="D7E4E1"/>
+                      </ns1:solidFill>
+                      <ns1:prstDash val="solid"/>
+                      <ns1:round/>
+                      <ns1:headEnd type="none" w="med" len="med"/>
+                      <ns1:tailEnd type="none" w="med" len="med"/>
+                    </ns1:lnL>
+                    <ns1:lnR w="12700" cap="flat" cmpd="sng" algn="ctr">
+                      <ns1:solidFill>
+                        <ns1:srgbClr val="D7E4E1"/>
+                      </ns1:solidFill>
+                      <ns1:prstDash val="solid"/>
+                      <ns1:round/>
+                      <ns1:headEnd type="none" w="med" len="med"/>
+                      <ns1:tailEnd type="none" w="med" len="med"/>
+                    </ns1:lnR>
+                    <ns1:lnT w="12700" cap="flat" cmpd="sng" algn="ctr">
+                      <ns1:solidFill>
+                        <ns1:srgbClr val="D7E4E1"/>
+                      </ns1:solidFill>
+                      <ns1:prstDash val="solid"/>
+                      <ns1:round/>
+                      <ns1:headEnd type="none" w="med" len="med"/>
+                      <ns1:tailEnd type="none" w="med" len="med"/>
+                    </ns1:lnT>
+                    <ns1:lnB w="12700" cap="flat" cmpd="sng" algn="ctr">
+                      <ns1:solidFill>
+                        <ns1:srgbClr val="D7E4E1"/>
+                      </ns1:solidFill>
+                      <ns1:prstDash val="solid"/>
+                      <ns1:round/>
+                      <ns1:headEnd type="none" w="med" len="med"/>
+                      <ns1:tailEnd type="none" w="med" len="med"/>
+                    </ns1:lnB>
+                    <ns1:solidFill>
+                      <ns1:srgbClr val="FFFFFF"/>
+                    </ns1:solidFill>
+                  </ns1:tcPr>
+                </ns1:tc>
+              </ns1:tr>
+              <ns1:tr h="548640">
+                <ns1:tc>
+                  <ns1:txBody>
+                    <ns1:bodyPr/>
+                    <ns1:lstStyle/>
+                    <ns1:p>
+                      <ns1:pPr indent="0" marL="0">
+                        <ns1:buNone/>
+                      </ns1:pPr>
+                      <ns1:r>
+                        <ns1:rPr lang="en-US" sz="1200" dirty="0">
+                          <ns1:solidFill>
+                            <ns1:srgbClr val="263538"/>
+                          </ns1:solidFill>
+                          <ns1:latin typeface="Arial" pitchFamily="34" charset="0"/>
+                          <ns1:ea typeface="Arial" pitchFamily="34" charset="-122"/>
+                          <ns1:cs typeface="Arial" pitchFamily="34" charset="-120"/>
+                        </ns1:rPr>
+                        <ns1:t>2</ns1:t>
+                      </ns1:r>
+                      <ns1:endParaRPr lang="en-US" sz="1200" dirty="0">
+                        <ns1:latin typeface="Arial" charset="0"/>
+                        <ns1:ea typeface="Arial" charset="0"/>
+                        <ns1:cs typeface="Arial" charset="0"/>
+                      </ns1:endParaRPr>
+                    </ns1:p>
+                  </ns1:txBody>
+                  <ns1:tcPr marL="73152" marR="73152" marT="73152" marB="73152" anchor="mid">
+                    <ns1:lnL w="12700" cap="flat" cmpd="sng" algn="ctr">
+                      <ns1:solidFill>
+                        <ns1:srgbClr val="D7E4E1"/>
+                      </ns1:solidFill>
+                      <ns1:prstDash val="solid"/>
+                      <ns1:round/>
+                      <ns1:headEnd type="none" w="med" len="med"/>
+                      <ns1:tailEnd type="none" w="med" len="med"/>
+                    </ns1:lnL>
+                    <ns1:lnR w="12700" cap="flat" cmpd="sng" algn="ctr">
+                      <ns1:solidFill>
+                        <ns1:srgbClr val="D7E4E1"/>
+                      </ns1:solidFill>
+                      <ns1:prstDash val="solid"/>
+                      <ns1:round/>
+                      <ns1:headEnd type="none" w="med" len="med"/>
+                      <ns1:tailEnd type="none" w="med" len="med"/>
+                    </ns1:lnR>
+                    <ns1:lnT w="12700" cap="flat" cmpd="sng" algn="ctr">
+                      <ns1:solidFill>
+                        <ns1:srgbClr val="D7E4E1"/>
+                      </ns1:solidFill>
+                      <ns1:prstDash val="solid"/>
+                      <ns1:round/>
+                      <ns1:headEnd type="none" w="med" len="med"/>
+                      <ns1:tailEnd type="none" w="med" len="med"/>
+                    </ns1:lnT>
+                    <ns1:lnB w="12700" cap="flat" cmpd="sng" algn="ctr">
+                      <ns1:solidFill>
+                        <ns1:srgbClr val="D7E4E1"/>
+                      </ns1:solidFill>
+                      <ns1:prstDash val="solid"/>
+                      <ns1:round/>
+                      <ns1:headEnd type="none" w="med" len="med"/>
+                      <ns1:tailEnd type="none" w="med" len="med"/>
+                    </ns1:lnB>
+                    <ns1:solidFill>
+                      <ns1:srgbClr val="FFFFFF"/>
+                    </ns1:solidFill>
+                  </ns1:tcPr>
+                </ns1:tc>
+                <ns1:tc>
+                  <ns1:txBody>
+                    <ns1:bodyPr/>
+                    <ns1:lstStyle/>
+                    <ns1:p>
+                      <ns1:pPr indent="0" marL="0">
+                        <ns1:buNone/>
+                      </ns1:pPr>
+                      <ns1:r>
+                        <ns1:rPr lang="en-US" sz="1200" dirty="0">
+                          <ns1:solidFill>
+                            <ns1:srgbClr val="263538"/>
+                          </ns1:solidFill>
+                          <ns1:latin typeface="Arial" pitchFamily="34" charset="0"/>
+                          <ns1:ea typeface="Arial" pitchFamily="34" charset="-122"/>
+                          <ns1:cs typeface="Arial" pitchFamily="34" charset="-120"/>
+                        </ns1:rPr>
+                        <ns1:t>31</ns1:t>
+                      </ns1:r>
+                      <ns1:endParaRPr lang="en-US" sz="1200" dirty="0">
+                        <ns1:latin typeface="Arial" charset="0"/>
+                        <ns1:ea typeface="Arial" charset="0"/>
+                        <ns1:cs typeface="Arial" charset="0"/>
+                      </ns1:endParaRPr>
+                    </ns1:p>
+                  </ns1:txBody>
+                  <ns1:tcPr marL="73152" marR="73152" marT="73152" marB="73152" anchor="mid">
+                    <ns1:lnL w="12700" cap="flat" cmpd="sng" algn="ctr">
+                      <ns1:solidFill>
+                        <ns1:srgbClr val="D7E4E1"/>
+                      </ns1:solidFill>
+                      <ns1:prstDash val="solid"/>
+                      <ns1:round/>
+                      <ns1:headEnd type="none" w="med" len="med"/>
+                      <ns1:tailEnd type="none" w="med" len="med"/>
+                    </ns1:lnL>
+                    <ns1:lnR w="12700" cap="flat" cmpd="sng" algn="ctr">
+                      <ns1:solidFill>
+                        <ns1:srgbClr val="D7E4E1"/>
+                      </ns1:solidFill>
+                      <ns1:prstDash val="solid"/>
+                      <ns1:round/>
+                      <ns1:headEnd type="none" w="med" len="med"/>
+                      <ns1:tailEnd type="none" w="med" len="med"/>
+                    </ns1:lnR>
+                    <ns1:lnT w="12700" cap="flat" cmpd="sng" algn="ctr">
+                      <ns1:solidFill>
+                        <ns1:srgbClr val="D7E4E1"/>
+                      </ns1:solidFill>
+                      <ns1:prstDash val="solid"/>
+                      <ns1:round/>
+                      <ns1:headEnd type="none" w="med" len="med"/>
+                      <ns1:tailEnd type="none" w="med" len="med"/>
+                    </ns1:lnT>
+                    <ns1:lnB w="12700" cap="flat" cmpd="sng" algn="ctr">
+                      <ns1:solidFill>
+                        <ns1:srgbClr val="D7E4E1"/>
+                      </ns1:solidFill>
+                      <ns1:prstDash val="solid"/>
+                      <ns1:round/>
+                      <ns1:headEnd type="none" w="med" len="med"/>
+                      <ns1:tailEnd type="none" w="med" len="med"/>
+                    </ns1:lnB>
+                    <ns1:solidFill>
+                      <ns1:srgbClr val="FFFFFF"/>
+                    </ns1:solidFill>
+                  </ns1:tcPr>
+                </ns1:tc>
+                <ns1:tc>
+                  <ns1:txBody>
+                    <ns1:bodyPr/>
+                    <ns1:lstStyle/>
+                    <ns1:p>
+                      <ns1:pPr indent="0" marL="0">
+                        <ns1:buNone/>
+                      </ns1:pPr>
+                      <ns1:r>
+                        <ns1:rPr lang="en-US" sz="1200" dirty="0">
+                          <ns1:solidFill>
+                            <ns1:srgbClr val="263538"/>
+                          </ns1:solidFill>
+                          <ns1:latin typeface="Arial" pitchFamily="34" charset="0"/>
+                          <ns1:ea typeface="Arial" pitchFamily="34" charset="-122"/>
+                          <ns1:cs typeface="Arial" pitchFamily="34" charset="-120"/>
+                        </ns1:rPr>
+                        <ns1:t>высокий уровень тревоги</ns1:t>
+                      </ns1:r>
+                      <ns1:endParaRPr lang="en-US" sz="1200" dirty="0">
+                        <ns1:latin typeface="Arial" charset="0"/>
+                        <ns1:ea typeface="Arial" charset="0"/>
+                        <ns1:cs typeface="Arial" charset="0"/>
+                      </ns1:endParaRPr>
+                    </ns1:p>
+                  </ns1:txBody>
+                  <ns1:tcPr marL="73152" marR="73152" marT="73152" marB="73152" anchor="mid">
+                    <ns1:lnL w="12700" cap="flat" cmpd="sng" algn="ctr">
+                      <ns1:solidFill>
+                        <ns1:srgbClr val="D7E4E1"/>
+                      </ns1:solidFill>
+                      <ns1:prstDash val="solid"/>
+                      <ns1:round/>
+                      <ns1:headEnd type="none" w="med" len="med"/>
+                      <ns1:tailEnd type="none" w="med" len="med"/>
+                    </ns1:lnL>
+                    <ns1:lnR w="12700" cap="flat" cmpd="sng" algn="ctr">
+                      <ns1:solidFill>
+                        <ns1:srgbClr val="D7E4E1"/>
+                      </ns1:solidFill>
+                      <ns1:prstDash val="solid"/>
+                      <ns1:round/>
+                      <ns1:headEnd type="none" w="med" len="med"/>
+                      <ns1:tailEnd type="none" w="med" len="med"/>
+                    </ns1:lnR>
+                    <ns1:lnT w="12700" cap="flat" cmpd="sng" algn="ctr">
+                      <ns1:solidFill>
+                        <ns1:srgbClr val="D7E4E1"/>
+                      </ns1:solidFill>
+                      <ns1:prstDash val="solid"/>
+                      <ns1:round/>
+                      <ns1:headEnd type="none" w="med" len="med"/>
+                      <ns1:tailEnd type="none" w="med" len="med"/>
+                    </ns1:lnT>
+                    <ns1:lnB w="12700" cap="flat" cmpd="sng" algn="ctr">
+                      <ns1:solidFill>
+                        <ns1:srgbClr val="D7E4E1"/>
+                      </ns1:solidFill>
+                      <ns1:prstDash val="solid"/>
+                      <ns1:round/>
+                      <ns1:headEnd type="none" w="med" len="med"/>
+                      <ns1:tailEnd type="none" w="med" len="med"/>
+                    </ns1:lnB>
+                    <ns1:solidFill>
+                      <ns1:srgbClr val="FFFFFF"/>
+                    </ns1:solidFill>
+                  </ns1:tcPr>
+                </ns1:tc>
+              </ns1:tr>
+              <ns1:tr h="548640">
+                <ns1:tc>
+                  <ns1:txBody>
+                    <ns1:bodyPr/>
+                    <ns1:lstStyle/>
+                    <ns1:p>
+                      <ns1:pPr indent="0" marL="0">
+                        <ns1:buNone/>
+                      </ns1:pPr>
+                      <ns1:r>
+                        <ns1:rPr lang="en-US" sz="1200" dirty="0">
+                          <ns1:solidFill>
+                            <ns1:srgbClr val="263538"/>
+                          </ns1:solidFill>
+                          <ns1:latin typeface="Arial" pitchFamily="34" charset="0"/>
+                          <ns1:ea typeface="Arial" pitchFamily="34" charset="-122"/>
+                          <ns1:cs typeface="Arial" pitchFamily="34" charset="-120"/>
+                        </ns1:rPr>
+                        <ns1:t>3</ns1:t>
+                      </ns1:r>
+                      <ns1:endParaRPr lang="en-US" sz="1200" dirty="0">
+                        <ns1:latin typeface="Arial" charset="0"/>
+                        <ns1:ea typeface="Arial" charset="0"/>
+                        <ns1:cs typeface="Arial" charset="0"/>
+                      </ns1:endParaRPr>
+                    </ns1:p>
+                  </ns1:txBody>
+                  <ns1:tcPr marL="73152" marR="73152" marT="73152" marB="73152" anchor="mid">
+                    <ns1:lnL w="12700" cap="flat" cmpd="sng" algn="ctr">
+                      <ns1:solidFill>
+                        <ns1:srgbClr val="D7E4E1"/>
+                      </ns1:solidFill>
+                      <ns1:prstDash val="solid"/>
+                      <ns1:round/>
+                      <ns1:headEnd type="none" w="med" len="med"/>
+                      <ns1:tailEnd type="none" w="med" len="med"/>
+                    </ns1:lnL>
+                    <ns1:lnR w="12700" cap="flat" cmpd="sng" algn="ctr">
+                      <ns1:solidFill>
+                        <ns1:srgbClr val="D7E4E1"/>
+                      </ns1:solidFill>
+                      <ns1:prstDash val="solid"/>
+                      <ns1:round/>
+                      <ns1:headEnd type="none" w="med" len="med"/>
+                      <ns1:tailEnd type="none" w="med" len="med"/>
+                    </ns1:lnR>
+                    <ns1:lnT w="12700" cap="flat" cmpd="sng" algn="ctr">
+                      <ns1:solidFill>
+                        <ns1:srgbClr val="D7E4E1"/>
+                      </ns1:solidFill>
+                      <ns1:prstDash val="solid"/>
+                      <ns1:round/>
+                      <ns1:headEnd type="none" w="med" len="med"/>
+                      <ns1:tailEnd type="none" w="med" len="med"/>
+                    </ns1:lnT>
+                    <ns1:lnB w="12700" cap="flat" cmpd="sng" algn="ctr">
+                      <ns1:solidFill>
+                        <ns1:srgbClr val="D7E4E1"/>
+                      </ns1:solidFill>
+                      <ns1:prstDash val="solid"/>
+                      <ns1:round/>
+                      <ns1:headEnd type="none" w="med" len="med"/>
+                      <ns1:tailEnd type="none" w="med" len="med"/>
+                    </ns1:lnB>
+                    <ns1:solidFill>
+                      <ns1:srgbClr val="FFFFFF"/>
+                    </ns1:solidFill>
+                  </ns1:tcPr>
+                </ns1:tc>
+                <ns1:tc>
+                  <ns1:txBody>
+                    <ns1:bodyPr/>
+                    <ns1:lstStyle/>
+                    <ns1:p>
+                      <ns1:pPr indent="0" marL="0">
+                        <ns1:buNone/>
+                      </ns1:pPr>
+                      <ns1:r>
+                        <ns1:rPr lang="en-US" sz="1200" dirty="0">
+                          <ns1:solidFill>
+                            <ns1:srgbClr val="263538"/>
+                          </ns1:solidFill>
+                          <ns1:latin typeface="Arial" pitchFamily="34" charset="0"/>
+                          <ns1:ea typeface="Arial" pitchFamily="34" charset="-122"/>
+                          <ns1:cs typeface="Arial" pitchFamily="34" charset="-120"/>
+                        </ns1:rPr>
+                        <ns1:t>29</ns1:t>
+                      </ns1:r>
+                      <ns1:endParaRPr lang="en-US" sz="1200" dirty="0">
+                        <ns1:latin typeface="Arial" charset="0"/>
+                        <ns1:ea typeface="Arial" charset="0"/>
+                        <ns1:cs typeface="Arial" charset="0"/>
+                      </ns1:endParaRPr>
+                    </ns1:p>
+                  </ns1:txBody>
+                  <ns1:tcPr marL="73152" marR="73152" marT="73152" marB="73152" anchor="mid">
+                    <ns1:lnL w="12700" cap="flat" cmpd="sng" algn="ctr">
+                      <ns1:solidFill>
+                        <ns1:srgbClr val="D7E4E1"/>
+                      </ns1:solidFill>
+                      <ns1:prstDash val="solid"/>
+                      <ns1:round/>
+                      <ns1:headEnd type="none" w="med" len="med"/>
+                      <ns1:tailEnd type="none" w="med" len="med"/>
+                    </ns1:lnL>
+                    <ns1:lnR w="12700" cap="flat" cmpd="sng" algn="ctr">
+                      <ns1:solidFill>
+                        <ns1:srgbClr val="D7E4E1"/>
+                      </ns1:solidFill>
+                      <ns1:prstDash val="solid"/>
+                      <ns1:round/>
+                      <ns1:headEnd type="none" w="med" len="med"/>
+                      <ns1:tailEnd type="none" w="med" len="med"/>
+                    </ns1:lnR>
+                    <ns1:lnT w="12700" cap="flat" cmpd="sng" algn="ctr">
+                      <ns1:solidFill>
+                        <ns1:srgbClr val="D7E4E1"/>
+                      </ns1:solidFill>
+                      <ns1:prstDash val="solid"/>
+                      <ns1:round/>
+                      <ns1:headEnd type="none" w="med" len="med"/>
+                      <ns1:tailEnd type="none" w="med" len="med"/>
+                    </ns1:lnT>
+                    <ns1:lnB w="12700" cap="flat" cmpd="sng" algn="ctr">
+                      <ns1:solidFill>
+                        <ns1:srgbClr val="D7E4E1"/>
+                      </ns1:solidFill>
+                      <ns1:prstDash val="solid"/>
+                      <ns1:round/>
+                      <ns1:headEnd type="none" w="med" len="med"/>
+                      <ns1:tailEnd type="none" w="med" len="med"/>
+                    </ns1:lnB>
+                    <ns1:solidFill>
+                      <ns1:srgbClr val="FFFFFF"/>
+                    </ns1:solidFill>
+                  </ns1:tcPr>
+                </ns1:tc>
+                <ns1:tc>
+                  <ns1:txBody>
+                    <ns1:bodyPr/>
+                    <ns1:lstStyle/>
+                    <ns1:p>
+                      <ns1:pPr indent="0" marL="0">
+                        <ns1:buNone/>
+                      </ns1:pPr>
+                      <ns1:r>
+                        <ns1:rPr lang="en-US" sz="1200" dirty="0">
+                          <ns1:solidFill>
+                            <ns1:srgbClr val="263538"/>
+                          </ns1:solidFill>
+                          <ns1:latin typeface="Arial" pitchFamily="34" charset="0"/>
+                          <ns1:ea typeface="Arial" pitchFamily="34" charset="-122"/>
+                          <ns1:cs typeface="Arial" pitchFamily="34" charset="-120"/>
+                        </ns1:rPr>
+                        <ns1:t>высокий уровень тревоги; результаты могут быть недостоверными</ns1:t>
+                      </ns1:r>
+                      <ns1:endParaRPr lang="en-US" sz="1200" dirty="0">
+                        <ns1:latin typeface="Arial" charset="0"/>
+                        <ns1:ea typeface="Arial" charset="0"/>
+                        <ns1:cs typeface="Arial" charset="0"/>
+                      </ns1:endParaRPr>
+                    </ns1:p>
+                  </ns1:txBody>
+                  <ns1:tcPr marL="73152" marR="73152" marT="73152" marB="73152" anchor="mid">
+                    <ns1:lnL w="12700" cap="flat" cmpd="sng" algn="ctr">
+                      <ns1:solidFill>
+                        <ns1:srgbClr val="D7E4E1"/>
+                      </ns1:solidFill>
+                      <ns1:prstDash val="solid"/>
+                      <ns1:round/>
+                      <ns1:headEnd type="none" w="med" len="med"/>
+                      <ns1:tailEnd type="none" w="med" len="med"/>
+                    </ns1:lnL>
+                    <ns1:lnR w="12700" cap="flat" cmpd="sng" algn="ctr">
+                      <ns1:solidFill>
+                        <ns1:srgbClr val="D7E4E1"/>
+                      </ns1:solidFill>
+                      <ns1:prstDash val="solid"/>
+                      <ns1:round/>
+                      <ns1:headEnd type="none" w="med" len="med"/>
+                      <ns1:tailEnd type="none" w="med" len="med"/>
+                    </ns1:lnR>
+                    <ns1:lnT w="12700" cap="flat" cmpd="sng" algn="ctr">
+                      <ns1:solidFill>
+                        <ns1:srgbClr val="D7E4E1"/>
+                      </ns1:solidFill>
+                      <ns1:prstDash val="solid"/>
+                      <ns1:round/>
+                      <ns1:headEnd type="none" w="med" len="med"/>
+                      <ns1:tailEnd type="none" w="med" len="med"/>
+                    </ns1:lnT>
+                    <ns1:lnB w="12700" cap="flat" cmpd="sng" algn="ctr">
+                      <ns1:solidFill>
+                        <ns1:srgbClr val="D7E4E1"/>
+                      </ns1:solidFill>
+                      <ns1:prstDash val="solid"/>
+                      <ns1:round/>
+                      <ns1:headEnd type="none" w="med" len="med"/>
+                      <ns1:tailEnd type="none" w="med" len="med"/>
+                    </ns1:lnB>
+                    <ns1:solidFill>
+                      <ns1:srgbClr val="FFFFFF"/>
+                    </ns1:solidFill>
+                  </ns1:tcPr>
+                </ns1:tc>
+              </ns1:tr>
+            </ns1:tbl>
+          </ns1:graphicData>
+        </ns1:graphic>
+      </ns0:graphicFrame>
+      <ns0:graphicFrame>
+        <ns0:nvGraphicFramePr>
+          <ns0:cNvPr id="5" name="Chart 0" descr=""/>
+          <ns0:cNvGraphicFramePr/>
+          <ns0:nvPr/>
+        </ns0:nvGraphicFramePr>
+        <ns0:xfrm>
+          <ns1:off x="7818120" y="1325880"/>
+          <ns1:ext cx="3383280" cy="2788920"/>
+        </ns0:xfrm>
+        <ns1:graphic>
+          <ns1:graphicData uri="http://schemas.openxmlformats.org/drawingml/2006/chart">
+            <ns3:chart ns4:id="rId1"/>
+          </ns1:graphicData>
+        </ns1:graphic>
+      </ns0:graphicFrame>
+      <ns0:sp>
+        <ns0:nvSpPr>
+          <ns0:cNvPr id="6" name="Shape 2"/>
+          <ns0:cNvSpPr/>
+          <ns0:nvPr/>
+        </ns0:nvSpPr>
+        <ns0:spPr>
+          <ns1:xfrm>
+            <ns1:off x="502920" y="6419088"/>
+            <ns1:ext cx="11155680" cy="0"/>
+          </ns1:xfrm>
+          <ns1:prstGeom prst="line">
+            <ns1:avLst/>
+          </ns1:prstGeom>
+          <ns1:noFill/>
+          <ns1:ln w="12700">
+            <ns1:solidFill>
+              <ns1:srgbClr val="D7E4E1"/>
+            </ns1:solidFill>
+            <ns1:prstDash val="solid"/>
+          </ns1:ln>
+        </ns0:spPr>
+      </ns0:sp>
+      <ns0:sp>
+        <ns0:nvSpPr>
+          <ns0:cNvPr id="7" name="Text 3"/>
+          <ns0:cNvSpPr/>
+          <ns0:nvPr/>
+        </ns0:nvSpPr>
+        <ns0:spPr>
+          <ns1:xfrm>
+            <ns1:off x="548640" y="6473952"/>
+            <ns1:ext cx="3931920" cy="201168"/>
+          </ns1:xfrm>
+          <ns1:prstGeom prst="rect">
+            <ns1:avLst/>
+          </ns1:prstGeom>
+          <ns1:noFill/>
+          <ns1:ln/>
+        </ns0:spPr>
+        <ns0:txBody>
+          <ns1:bodyPr wrap="square" rtlCol="0" anchor="ctr"/>
+          <ns1:lstStyle/>
+          <ns1:p>
+            <ns1:pPr indent="0" marL="0">
+              <ns1:buNone/>
+            </ns1:pPr>
+            <ns1:r>
+              <ns1:rPr lang="en-US" sz="850" dirty="0">
+                <ns1:solidFill>
+                  <ns1:srgbClr val="66797C"/>
+                </ns1:solidFill>
+                <ns1:latin typeface="Arial" pitchFamily="34" charset="0"/>
+                <ns1:ea typeface="Arial" pitchFamily="34" charset="-122"/>
+                <ns1:cs typeface="Arial" pitchFamily="34" charset="-120"/>
+              </ns1:rPr>
+              <ns1:t>[ФИО] | [Группа]</ns1:t>
+            </ns1:r>
+            <ns1:endParaRPr lang="en-US" sz="850" dirty="0"/>
+          </ns1:p>
+        </ns0:txBody>
+      </ns0:sp>
+      <ns0:sp>
+        <ns0:nvSpPr>
+          <ns0:cNvPr id="8" name="Text 4"/>
+          <ns0:cNvSpPr/>
+          <ns0:nvPr/>
+        </ns0:nvSpPr>
+        <ns0:spPr>
+          <ns1:xfrm>
+            <ns1:off x="11201400" y="6473952"/>
+            <ns1:ext cx="411480" cy="201168"/>
+          </ns1:xfrm>
+          <ns1:prstGeom prst="rect">
+            <ns1:avLst/>
+          </ns1:prstGeom>
+          <ns1:noFill/>
+          <ns1:ln/>
+        </ns0:spPr>
+        <ns0:txBody>
+          <ns1:bodyPr wrap="square" rtlCol="0" anchor="ctr"/>
+          <ns1:lstStyle/>
+          <ns1:p>
+            <ns1:pPr algn="r" indent="0" marL="0">
+              <ns1:buNone/>
+            </ns1:pPr>
+            <ns1:r>
+              <ns1:rPr lang="en-US" sz="850" dirty="0">
+                <ns1:solidFill>
+                  <ns1:srgbClr val="66797C"/>
+                </ns1:solidFill>
+                <ns1:latin typeface="Arial" pitchFamily="34" charset="0"/>
+                <ns1:ea typeface="Arial" pitchFamily="34" charset="-122"/>
+                <ns1:cs typeface="Arial" pitchFamily="34" charset="-120"/>
+              </ns1:rPr>
+              <ns1:t>5</ns1:t>
+            </ns1:r>
+            <ns1:endParaRPr lang="en-US" sz="850" dirty="0"/>
+          </ns1:p>
+        </ns0:txBody>
+      </ns0:sp>
+    </ns0:spTree>
+  </ns0:cSld>
+  <ns0:clrMapOvr>
+    <ns1:masterClrMapping/>
+  </ns0:clrMapOvr>
+</ns0:sld>
 </file>
 
 <file path=ppt/slides/slide6.xml><?xml version="1.0" encoding="utf-8"?>

</xml_diff>